<commit_message>
Admin Panel - Admin profile update (part - 3)
</commit_message>
<xml_diff>
--- a/.lessons/49 Admin Panel Setup And Mastering/8 Admin Panel - Admin profile update (part - 2)/1.pptx
+++ b/.lessons/49 Admin Panel Setup And Mastering/8 Admin Panel - Admin profile update (part - 2)/1.pptx
@@ -4176,8 +4176,8 @@
         </p:nvSpPr>
         <p:spPr>
           <a:xfrm>
-            <a:off x="217714" y="255046"/>
-            <a:ext cx="11756571" cy="355354"/>
+            <a:off x="217715" y="255046"/>
+            <a:ext cx="5536163" cy="3056093"/>
           </a:xfrm>
           <a:prstGeom prst="rect">
             <a:avLst/>
@@ -4201,6 +4201,156 @@
                 <a:latin typeface="Arial" panose="020B0604020202020204" pitchFamily="34" charset="0"/>
               </a:rPr>
               <a:t>Şəkli əlavə edə bilmək üçün controllerə kodumuzu yazırıq.</a:t>
+            </a:r>
+          </a:p>
+          <a:p>
+            <a:pPr>
+              <a:lnSpc>
+                <a:spcPct val="150000"/>
+              </a:lnSpc>
+              <a:buNone/>
+            </a:pPr>
+            <a:endParaRPr kumimoji="0" lang="az-Latn-AZ" altLang="en-US" sz="1300" b="0" i="0" u="none" strike="noStrike" cap="none" normalizeH="0" baseline="0">
+              <a:ln>
+                <a:noFill/>
+              </a:ln>
+              <a:solidFill>
+                <a:schemeClr val="tx1"/>
+              </a:solidFill>
+              <a:effectLst/>
+              <a:latin typeface="Arial" panose="020B0604020202020204" pitchFamily="34" charset="0"/>
+            </a:endParaRPr>
+          </a:p>
+          <a:p>
+            <a:pPr>
+              <a:lnSpc>
+                <a:spcPct val="150000"/>
+              </a:lnSpc>
+              <a:buNone/>
+            </a:pPr>
+            <a:endParaRPr lang="az-Latn-AZ" altLang="en-US" sz="1300">
+              <a:latin typeface="Arial" panose="020B0604020202020204" pitchFamily="34" charset="0"/>
+            </a:endParaRPr>
+          </a:p>
+          <a:p>
+            <a:pPr>
+              <a:lnSpc>
+                <a:spcPct val="150000"/>
+              </a:lnSpc>
+              <a:buNone/>
+            </a:pPr>
+            <a:r>
+              <a:rPr lang="en-US" altLang="en-US" sz="1300" b="1">
+                <a:latin typeface="Arial" panose="020B0604020202020204" pitchFamily="34" charset="0"/>
+              </a:rPr>
+              <a:t>'unique:users,email,' . Auth::user()-&gt;id </a:t>
+            </a:r>
+            <a:r>
+              <a:rPr lang="en-US" altLang="en-US" sz="1300">
+                <a:latin typeface="Arial" panose="020B0604020202020204" pitchFamily="34" charset="0"/>
+              </a:rPr>
+              <a:t>bu validasiya qaydası e-mail sahəsinin unikallığını yoxlayır, amma hazırda daxil olmuş istifadəçinin öz </a:t>
+            </a:r>
+            <a:r>
+              <a:rPr lang="az-Latn-AZ" altLang="en-US" sz="1300">
+                <a:latin typeface="Arial" panose="020B0604020202020204" pitchFamily="34" charset="0"/>
+              </a:rPr>
+              <a:t> </a:t>
+            </a:r>
+            <a:r>
+              <a:rPr lang="en-US" altLang="en-US" sz="1300">
+                <a:latin typeface="Arial" panose="020B0604020202020204" pitchFamily="34" charset="0"/>
+              </a:rPr>
+              <a:t>e-mailini istisna edir.</a:t>
+            </a:r>
+            <a:endParaRPr lang="az-Latn-AZ" altLang="en-US" sz="1300">
+              <a:latin typeface="Arial" panose="020B0604020202020204" pitchFamily="34" charset="0"/>
+            </a:endParaRPr>
+          </a:p>
+          <a:p>
+            <a:pPr>
+              <a:lnSpc>
+                <a:spcPct val="150000"/>
+              </a:lnSpc>
+              <a:buNone/>
+            </a:pPr>
+            <a:endParaRPr kumimoji="0" lang="az-Latn-AZ" altLang="en-US" sz="1300" b="0" i="0" u="none" strike="noStrike" cap="none" normalizeH="0" baseline="0">
+              <a:ln>
+                <a:noFill/>
+              </a:ln>
+              <a:solidFill>
+                <a:schemeClr val="tx1"/>
+              </a:solidFill>
+              <a:effectLst/>
+              <a:latin typeface="Arial" panose="020B0604020202020204" pitchFamily="34" charset="0"/>
+            </a:endParaRPr>
+          </a:p>
+          <a:p>
+            <a:pPr>
+              <a:lnSpc>
+                <a:spcPct val="150000"/>
+              </a:lnSpc>
+              <a:buNone/>
+            </a:pPr>
+            <a:r>
+              <a:rPr lang="az-Latn-AZ" altLang="en-US" sz="1300" b="1">
+                <a:latin typeface="Arial" panose="020B0604020202020204" pitchFamily="34" charset="0"/>
+              </a:rPr>
+              <a:t>Yəni, başqa sözlə desək bu, deməkdir ki</a:t>
+            </a:r>
+            <a:r>
+              <a:rPr lang="az-Latn-AZ" altLang="en-US" sz="1300">
+                <a:latin typeface="Arial" panose="020B0604020202020204" pitchFamily="34" charset="0"/>
+              </a:rPr>
+              <a:t>: </a:t>
+            </a:r>
+            <a:r>
+              <a:rPr lang="az-Latn-AZ" altLang="en-US" sz="1300" b="1">
+                <a:latin typeface="Arial" panose="020B0604020202020204" pitchFamily="34" charset="0"/>
+              </a:rPr>
+              <a:t>users</a:t>
+            </a:r>
+            <a:r>
+              <a:rPr lang="az-Latn-AZ" altLang="en-US" sz="1300">
+                <a:latin typeface="Arial" panose="020B0604020202020204" pitchFamily="34" charset="0"/>
+              </a:rPr>
+              <a:t> cədvəlində </a:t>
+            </a:r>
+            <a:r>
+              <a:rPr lang="az-Latn-AZ" altLang="en-US" sz="1300" b="1">
+                <a:latin typeface="Arial" panose="020B0604020202020204" pitchFamily="34" charset="0"/>
+              </a:rPr>
+              <a:t>email</a:t>
+            </a:r>
+            <a:r>
+              <a:rPr lang="az-Latn-AZ" altLang="en-US" sz="1300">
+                <a:latin typeface="Arial" panose="020B0604020202020204" pitchFamily="34" charset="0"/>
+              </a:rPr>
+              <a:t> sütununda eyni dəyərin olub-olmadığını yoxla, amma </a:t>
+            </a:r>
+            <a:r>
+              <a:rPr lang="az-Latn-AZ" altLang="en-US" sz="1300" b="1">
+                <a:latin typeface="Arial" panose="020B0604020202020204" pitchFamily="34" charset="0"/>
+              </a:rPr>
+              <a:t>id</a:t>
+            </a:r>
+            <a:r>
+              <a:rPr lang="az-Latn-AZ" altLang="en-US" sz="1300">
+                <a:latin typeface="Arial" panose="020B0604020202020204" pitchFamily="34" charset="0"/>
+              </a:rPr>
+              <a:t>-si hazırkı istifadəçinin </a:t>
+            </a:r>
+            <a:r>
+              <a:rPr lang="az-Latn-AZ" altLang="en-US" sz="1300" b="1">
+                <a:latin typeface="Arial" panose="020B0604020202020204" pitchFamily="34" charset="0"/>
+              </a:rPr>
+              <a:t>id</a:t>
+            </a:r>
+            <a:r>
+              <a:rPr lang="az-Latn-AZ" altLang="en-US" sz="1300">
+                <a:latin typeface="Arial" panose="020B0604020202020204" pitchFamily="34" charset="0"/>
+              </a:rPr>
+              <a:t>-sinə bərabər olan sətri nəzərə alma.</a:t>
             </a:r>
             <a:endParaRPr kumimoji="0" lang="en-US" altLang="en-US" sz="1300" b="0" i="0" u="none" strike="noStrike" cap="none" normalizeH="0" baseline="0">
               <a:ln>

</xml_diff>